<commit_message>
Revert "feat(embed): let the shell trust its own origins, so live embeds can run"
This reverts commit 0647fb4c52adf02e95702ba16a0be58508fae17c.
</commit_message>
<xml_diff>
--- a/decks/mobilitetsatlas-intro/Mobilitetsatlas-introduktion.pptx
+++ b/decks/mobilitetsatlas-intro/Mobilitetsatlas-introduktion.pptx
@@ -2563,7 +2563,7 @@
           <a:p>
             <a:r>
               <a:rPr lang="en-US" dirty="0"/>
-              <a:t>This map is live in the slide — drag it, zoom, toggle the routes and the frequency. It is the atlas itself, not a screenshot. Three things to point at: the detailed map with cell-level grades, the five-year trend from Statistics Denmark, and "Ask about mobility", which answers from your own municipal and regional plans with the source documents linked. All of it CC BY-SA: screenshot it, quote it, put it in your own papers.</a:t>
+              <a:t>This is your municipality's page, and the URL is on the slide — open it in a browser tab if you want to drive it live. Three things to point at: the detailed map with cell-level grades, the five-year trend from Statistics Denmark, and "Ask about mobility", which answers from your own municipal and regional plans with the source documents linked. All of it CC BY-SA: screenshot it, quote it, put it in your own papers.</a:t>
             </a:r>
             <a:endParaRPr lang="en-US" dirty="0"/>
           </a:p>
@@ -2827,7 +2827,7 @@
           <a:p>
             <a:r>
               <a:rPr lang="en-US" dirty="0"/>
-              <a:t>This one is live too — the horizontal axis is a dropdown: spending per resident, car ownership, population density, road casualties. The table underneath sorts on both measures. Worth opening in a browser tab if the room starts asking "what about X".</a:t>
+              <a:t>On the site the horizontal axis is a dropdown: spending per resident, car ownership, population density, road casualties. The table underneath sorts on both measures. Worth opening in a browser tab if the room starts asking "what about X".</a:t>
             </a:r>
             <a:endParaRPr lang="en-US" dirty="0"/>
           </a:p>
@@ -5931,7 +5931,7 @@
                 <a:ea typeface="Playfair Display" pitchFamily="34" charset="-122"/>
                 <a:cs typeface="Playfair Display" pitchFamily="34" charset="-120"/>
               </a:rPr>
-              <a:t>Aarhus, live on the map</a:t>
+              <a:t>Every municipality has a page</a:t>
             </a:r>
             <a:endParaRPr lang="en-US" sz="3000" dirty="0"/>
           </a:p>
@@ -6060,7 +6060,7 @@
                 <a:ea typeface="DM Mono" pitchFamily="34" charset="-122"/>
                 <a:cs typeface="DM Mono" pitchFamily="34" charset="-120"/>
               </a:rPr>
-              <a:t>mobilitetsatlas.dk/en/embed/kommune/aarhus  ·  CC BY-SA 4.0</a:t>
+              <a:t>mobilitetsatlas.dk/en/kommune/aarhus  ·  CC BY-SA 4.0</a:t>
             </a:r>
             <a:endParaRPr lang="en-US" sz="975" dirty="0"/>
           </a:p>
@@ -7418,7 +7418,7 @@
                 <a:ea typeface="Playfair Display" pitchFamily="34" charset="-122"/>
                 <a:cs typeface="Playfair Display" pitchFamily="34" charset="-120"/>
               </a:rPr>
-              <a:t>Explore, live</a:t>
+              <a:t>Compare on any measure</a:t>
             </a:r>
             <a:endParaRPr lang="en-US" sz="3000" dirty="0"/>
           </a:p>
@@ -7644,7 +7644,7 @@
                 <a:ea typeface="Inter" pitchFamily="34" charset="-122"/>
                 <a:cs typeface="Inter" pitchFamily="34" charset="-120"/>
               </a:rPr>
-              <a:t>This map is </a:t>
+              <a:t>On the live map, press </a:t>
             </a:r>
             <a:pPr algn="l" indent="0" marL="0">
               <a:lnSpc>
@@ -7661,7 +7661,7 @@
                 <a:ea typeface="Inter" pitchFamily="34" charset="-122"/>
                 <a:cs typeface="Inter" pitchFamily="34" charset="-120"/>
               </a:rPr>
-              <a:t>live</a:t>
+              <a:t>Byvisning</a:t>
             </a:r>
             <a:pPr algn="l" indent="0" marL="0">
               <a:lnSpc>
@@ -7678,7 +7678,7 @@
                 <a:ea typeface="Inter" pitchFamily="34" charset="-122"/>
                 <a:cs typeface="Inter" pitchFamily="34" charset="-120"/>
               </a:rPr>
-              <a:t>: drag it, zoom in, and the buildings rise as the day's scheduled services move across them.</a:t>
+              <a:t> and zoom in: the buildings rise and the day's scheduled services move across them.</a:t>
             </a:r>
             <a:endParaRPr lang="en-US" sz="1125" dirty="0"/>
           </a:p>

</xml_diff>

<commit_message>
Reapply "feat(embed): let the shell trust its own origins, so live embeds can run"
This reverts commit 94586bcfd77957c637845026b7d5953a13cdfec4.
</commit_message>
<xml_diff>
--- a/decks/mobilitetsatlas-intro/Mobilitetsatlas-introduktion.pptx
+++ b/decks/mobilitetsatlas-intro/Mobilitetsatlas-introduktion.pptx
@@ -2563,7 +2563,7 @@
           <a:p>
             <a:r>
               <a:rPr lang="en-US" dirty="0"/>
-              <a:t>This is your municipality's page, and the URL is on the slide — open it in a browser tab if you want to drive it live. Three things to point at: the detailed map with cell-level grades, the five-year trend from Statistics Denmark, and "Ask about mobility", which answers from your own municipal and regional plans with the source documents linked. All of it CC BY-SA: screenshot it, quote it, put it in your own papers.</a:t>
+              <a:t>This map is live in the slide — drag it, zoom, toggle the routes and the frequency. It is the atlas itself, not a screenshot. Three things to point at: the detailed map with cell-level grades, the five-year trend from Statistics Denmark, and "Ask about mobility", which answers from your own municipal and regional plans with the source documents linked. All of it CC BY-SA: screenshot it, quote it, put it in your own papers.</a:t>
             </a:r>
             <a:endParaRPr lang="en-US" dirty="0"/>
           </a:p>
@@ -2827,7 +2827,7 @@
           <a:p>
             <a:r>
               <a:rPr lang="en-US" dirty="0"/>
-              <a:t>On the site the horizontal axis is a dropdown: spending per resident, car ownership, population density, road casualties. The table underneath sorts on both measures. Worth opening in a browser tab if the room starts asking "what about X".</a:t>
+              <a:t>This one is live too — the horizontal axis is a dropdown: spending per resident, car ownership, population density, road casualties. The table underneath sorts on both measures. Worth opening in a browser tab if the room starts asking "what about X".</a:t>
             </a:r>
             <a:endParaRPr lang="en-US" dirty="0"/>
           </a:p>
@@ -5931,7 +5931,7 @@
                 <a:ea typeface="Playfair Display" pitchFamily="34" charset="-122"/>
                 <a:cs typeface="Playfair Display" pitchFamily="34" charset="-120"/>
               </a:rPr>
-              <a:t>Every municipality has a page</a:t>
+              <a:t>Aarhus, live on the map</a:t>
             </a:r>
             <a:endParaRPr lang="en-US" sz="3000" dirty="0"/>
           </a:p>
@@ -6060,7 +6060,7 @@
                 <a:ea typeface="DM Mono" pitchFamily="34" charset="-122"/>
                 <a:cs typeface="DM Mono" pitchFamily="34" charset="-120"/>
               </a:rPr>
-              <a:t>mobilitetsatlas.dk/en/kommune/aarhus  ·  CC BY-SA 4.0</a:t>
+              <a:t>mobilitetsatlas.dk/en/embed/kommune/aarhus  ·  CC BY-SA 4.0</a:t>
             </a:r>
             <a:endParaRPr lang="en-US" sz="975" dirty="0"/>
           </a:p>
@@ -7418,7 +7418,7 @@
                 <a:ea typeface="Playfair Display" pitchFamily="34" charset="-122"/>
                 <a:cs typeface="Playfair Display" pitchFamily="34" charset="-120"/>
               </a:rPr>
-              <a:t>Compare on any measure</a:t>
+              <a:t>Explore, live</a:t>
             </a:r>
             <a:endParaRPr lang="en-US" sz="3000" dirty="0"/>
           </a:p>
@@ -7644,7 +7644,7 @@
                 <a:ea typeface="Inter" pitchFamily="34" charset="-122"/>
                 <a:cs typeface="Inter" pitchFamily="34" charset="-120"/>
               </a:rPr>
-              <a:t>On the live map, press </a:t>
+              <a:t>This map is </a:t>
             </a:r>
             <a:pPr algn="l" indent="0" marL="0">
               <a:lnSpc>
@@ -7661,7 +7661,7 @@
                 <a:ea typeface="Inter" pitchFamily="34" charset="-122"/>
                 <a:cs typeface="Inter" pitchFamily="34" charset="-120"/>
               </a:rPr>
-              <a:t>Byvisning</a:t>
+              <a:t>live</a:t>
             </a:r>
             <a:pPr algn="l" indent="0" marL="0">
               <a:lnSpc>
@@ -7678,7 +7678,7 @@
                 <a:ea typeface="Inter" pitchFamily="34" charset="-122"/>
                 <a:cs typeface="Inter" pitchFamily="34" charset="-120"/>
               </a:rPr>
-              <a:t> and zoom in: the buildings rise and the day's scheduled services move across them.</a:t>
+              <a:t>: drag it, zoom in, and the buildings rise as the day's scheduled services move across them.</a:t>
             </a:r>
             <a:endParaRPr lang="en-US" sz="1125" dirty="0"/>
           </a:p>

</xml_diff>

<commit_message>
feat(deck): point the live maps at staging, now that the embed route is merged
betamobility/dk-mobility#230 is squash-merged into staging, so
/embed/kommune/<slug> ships there first; dk-mobility promotes to
production as a separate release. Byvisning's city artifact is
staging-only regardless, so all three live surfaces point at
staging.mobilitetsatlas.dk. The embed route carries no chrome, so nothing
in the frame reads "Testversion" — the difference from production is the
data edition, not the look.

Co-Authored-By: Claude Opus 5 <noreply@anthropic.com>
</commit_message>
<xml_diff>
--- a/decks/mobilitetsatlas-intro/Mobilitetsatlas-introduktion.pptx
+++ b/decks/mobilitetsatlas-intro/Mobilitetsatlas-introduktion.pptx
@@ -6060,7 +6060,7 @@
                 <a:ea typeface="DM Mono" pitchFamily="34" charset="-122"/>
                 <a:cs typeface="DM Mono" pitchFamily="34" charset="-120"/>
               </a:rPr>
-              <a:t>mobilitetsatlas.dk/en/embed/kommune/aarhus  ·  CC BY-SA 4.0</a:t>
+              <a:t>mobilitetsatlas.dk/en/kommune/aarhus  ·  CC BY-SA 4.0</a:t>
             </a:r>
             <a:endParaRPr lang="en-US" sz="975" dirty="0"/>
           </a:p>
@@ -7483,7 +7483,7 @@
                 <a:ea typeface="DM Mono" pitchFamily="34" charset="-122"/>
                 <a:cs typeface="DM Mono" pitchFamily="34" charset="-120"/>
               </a:rPr>
-              <a:t>mobilitetsatlas.dk/en/udforsk?x=families_with_car_pct  ·  ←  back</a:t>
+              <a:t>mobilitetsatlas.dk/en/udforsk  ·  ←  back</a:t>
             </a:r>
             <a:endParaRPr lang="en-US" sz="975" dirty="0"/>
           </a:p>

</xml_diff>